<commit_message>
Mark AI features as built in PRD, pitch script, and deck
The four Phase 3 AI features (live captions, interpreter translation, hearing
summaries, predictive wait-times) are implemented, so update the docs/deck from
'proposed/roadmap' to 'built' (with honest nuance: captions in-browser,
translation/summaries hosted-model-with-fallback, wait-times heuristic).

- PRD: new section 7.11 AI assistance (FR-AI-1..5); roadmap Phase 3 updated.
- PITCH_SCRIPT: AI Involvement + Future Plans Phase 3 updated.
- generate-deck.js: AI slide + Future Plans slide updated; deck regenerated.

Co-Authored-By: Claude Opus 4.8 <noreply@anthropic.com>
</commit_message>
<xml_diff>
--- a/VWR-Pitch-Deck.pptx
+++ b/VWR-Pitch-Deck.pptx
@@ -3634,7 +3634,7 @@
                 <a:ea typeface="Arial" pitchFamily="34" charset="-122"/>
                 <a:cs typeface="Arial" pitchFamily="34" charset="-120"/>
               </a:rPr>
-              <a:t>Phase 3 — AI-Augment</a:t>
+              <a:t>Phase 3 — AI-Augment ✓ built</a:t>
             </a:r>
             <a:endParaRPr lang="en-US" sz="1150" dirty="0"/>
           </a:p>
@@ -3677,7 +3677,7 @@
                 <a:ea typeface="Arial" pitchFamily="34" charset="-122"/>
                 <a:cs typeface="Arial" pitchFamily="34" charset="-120"/>
               </a:rPr>
-              <a:t>Live captions / transcription</a:t>
+              <a:t>Live captions / transcription ✓</a:t>
             </a:r>
             <a:endParaRPr lang="en-US" sz="1050" dirty="0"/>
           </a:p>
@@ -3698,7 +3698,7 @@
                 <a:ea typeface="Arial" pitchFamily="34" charset="-122"/>
                 <a:cs typeface="Arial" pitchFamily="34" charset="-120"/>
               </a:rPr>
-              <a:t>Translation assist for interpreters</a:t>
+              <a:t>Translation assist for interpreters ✓</a:t>
             </a:r>
             <a:endParaRPr lang="en-US" sz="1050" dirty="0"/>
           </a:p>
@@ -3719,7 +3719,7 @@
                 <a:ea typeface="Arial" pitchFamily="34" charset="-122"/>
                 <a:cs typeface="Arial" pitchFamily="34" charset="-120"/>
               </a:rPr>
-              <a:t>Automated hearing summaries</a:t>
+              <a:t>Automated hearing summaries ✓</a:t>
             </a:r>
             <a:endParaRPr lang="en-US" sz="1050" dirty="0"/>
           </a:p>
@@ -3740,7 +3740,28 @@
                 <a:ea typeface="Arial" pitchFamily="34" charset="-122"/>
                 <a:cs typeface="Arial" pitchFamily="34" charset="-120"/>
               </a:rPr>
-              <a:t>Predictive wait-times</a:t>
+              <a:t>Predictive wait-times ✓</a:t>
+            </a:r>
+            <a:endParaRPr lang="en-US" sz="1050" dirty="0"/>
+          </a:p>
+          <a:p>
+            <a:pPr marL="342900" indent="-342900">
+              <a:spcAft>
+                <a:spcPts val="800"/>
+              </a:spcAft>
+              <a:buSzPct val="100000"/>
+              <a:buChar char="•"/>
+            </a:pPr>
+            <a:r>
+              <a:rPr lang="en-US" sz="1050" dirty="0">
+                <a:solidFill>
+                  <a:srgbClr val="1B1B1B"/>
+                </a:solidFill>
+                <a:latin typeface="Arial" pitchFamily="34" charset="0"/>
+                <a:ea typeface="Arial" pitchFamily="34" charset="-122"/>
+                <a:cs typeface="Arial" pitchFamily="34" charset="-120"/>
+              </a:rPr>
+              <a:t>Next: accuracy + legal-record handling</a:t>
             </a:r>
             <a:endParaRPr lang="en-US" sz="1050" dirty="0"/>
           </a:p>
@@ -10890,7 +10911,7 @@
                 <a:ea typeface="Arial" pitchFamily="34" charset="-122"/>
                 <a:cs typeface="Arial" pitchFamily="34" charset="-120"/>
               </a:rPr>
-              <a:t>How AI built it today — and where AI takes the product next</a:t>
+              <a:t>Built with AI — and four AI features now built into the product</a:t>
             </a:r>
             <a:endParaRPr lang="en-US" sz="1300" dirty="0"/>
           </a:p>
@@ -11137,7 +11158,7 @@
                 <a:ea typeface="Arial" pitchFamily="34" charset="-122"/>
                 <a:cs typeface="Arial" pitchFamily="34" charset="-120"/>
               </a:rPr>
-              <a:t>AI on the Roadmap  (proposed)</a:t>
+              <a:t>AI IN the Product  (built)</a:t>
             </a:r>
             <a:endParaRPr lang="en-US" sz="1500" dirty="0"/>
           </a:p>
@@ -11180,7 +11201,7 @@
                 <a:ea typeface="Arial" pitchFamily="34" charset="-122"/>
                 <a:cs typeface="Arial" pitchFamily="34" charset="-120"/>
               </a:rPr>
-              <a:t>Live transcription &amp; captioning — for the record and accessibility.</a:t>
+              <a:t>Live captions &amp; transcription in the hearing (in-browser).</a:t>
             </a:r>
             <a:endParaRPr lang="en-US" sz="1300" dirty="0"/>
           </a:p>
@@ -11222,7 +11243,7 @@
                 <a:ea typeface="Arial" pitchFamily="34" charset="-122"/>
                 <a:cs typeface="Arial" pitchFamily="34" charset="-120"/>
               </a:rPr>
-              <a:t>Predictive wait-times to rebalance dockets.</a:t>
+              <a:t>Automated hearing summaries drafted for the judge.</a:t>
             </a:r>
             <a:endParaRPr lang="en-US" sz="1300" dirty="0"/>
           </a:p>
@@ -11243,7 +11264,7 @@
                 <a:ea typeface="Arial" pitchFamily="34" charset="-122"/>
                 <a:cs typeface="Arial" pitchFamily="34" charset="-120"/>
               </a:rPr>
-              <a:t>Automated hearing summaries drafted for the judge.</a:t>
+              <a:t>Predictive wait-times to rebalance the docket.</a:t>
             </a:r>
             <a:endParaRPr lang="en-US" sz="1300" dirty="0"/>
           </a:p>
@@ -11721,8 +11742,8 @@
         </p:nvSpPr>
         <p:spPr>
           <a:xfrm>
-            <a:off x="6217920" y="4434840"/>
-            <a:ext cx="5486400" cy="274320"/>
+            <a:off x="6217920" y="4389120"/>
+            <a:ext cx="5486400" cy="548640"/>
           </a:xfrm>
           <a:prstGeom prst="rect">
             <a:avLst/>
@@ -11738,7 +11759,7 @@
               <a:buNone/>
             </a:pPr>
             <a:r>
-              <a:rPr lang="en-US" sz="1000" i="1" dirty="0">
+              <a:rPr lang="en-US" sz="950" i="1" dirty="0">
                 <a:solidFill>
                   <a:srgbClr val="4A4D4F"/>
                 </a:solidFill>
@@ -11746,9 +11767,9 @@
                 <a:ea typeface="Arial" pitchFamily="34" charset="-122"/>
                 <a:cs typeface="Arial" pitchFamily="34" charset="-120"/>
               </a:rPr>
-              <a:t>Proposed features are roadmap, not live in the demo.</a:t>
-            </a:r>
-            <a:endParaRPr lang="en-US" sz="1000" dirty="0"/>
+              <a:t>Built &amp; demoable. Translation/summaries use a hosted model when an API key is set, with an offline fallback; captions are in-browser; wait-times are a live heuristic.</a:t>
+            </a:r>
+            <a:endParaRPr lang="en-US" sz="950" dirty="0"/>
           </a:p>
         </p:txBody>
       </p:sp>

</xml_diff>

<commit_message>
Update pitch deck for latest features (multilingual, captions, real recording)
- Slide 3: multilingual UI bullet; conferencing column -> 'In-house Video + AI'
  (captions, translation, summaries, server-saved recording).
- Slide 7: feature chips updated (live captions, interpreter translation, AI summary,
  recording saved).
- Slide 9: fix stale nys-unavheader/nys-skipnav -> nys-globalheader; add multilingual
  + RTL; refresh summary box.
- Slide 6: flow caption aligned with the at-least-one readiness rule.

Co-Authored-By: Claude Opus 4.8 <noreply@anthropic.com>
</commit_message>
<xml_diff>
--- a/VWR-Pitch-Deck.pptx
+++ b/VWR-Pitch-Deck.pptx
@@ -5166,7 +5166,7 @@
                 <a:ea typeface="Arial" pitchFamily="34" charset="-122"/>
                 <a:cs typeface="Arial" pitchFamily="34" charset="-120"/>
               </a:rPr>
-              <a:t>Readiness state machine — hearing unlocks only when all required parties are ready.</a:t>
+              <a:t>Readiness state machine gates when a hearing can start.</a:t>
             </a:r>
             <a:endParaRPr lang="en-US" sz="1300" dirty="0"/>
           </a:p>
@@ -5187,7 +5187,7 @@
                 <a:ea typeface="Arial" pitchFamily="34" charset="-122"/>
                 <a:cs typeface="Arial" pitchFamily="34" charset="-120"/>
               </a:rPr>
-              <a:t>Judge controls: call/recall, deny, start, reassign, close + disposition.</a:t>
+              <a:t>Judge controls: call/recall, deny, start, reassign, close.</a:t>
             </a:r>
             <a:endParaRPr lang="en-US" sz="1300" dirty="0"/>
           </a:p>
@@ -5208,7 +5208,7 @@
                 <a:ea typeface="Arial" pitchFamily="34" charset="-122"/>
                 <a:cs typeface="Arial" pitchFamily="34" charset="-120"/>
               </a:rPr>
-              <a:t>Supervisor oversight dashboard: search, sort, filter, live statuses.</a:t>
+              <a:t>Supervisor oversight: search, sort, filter, live statuses, recordings.</a:t>
             </a:r>
             <a:endParaRPr lang="en-US" sz="1300" dirty="0"/>
           </a:p>
@@ -5229,7 +5229,7 @@
                 <a:ea typeface="Arial" pitchFamily="34" charset="-122"/>
                 <a:cs typeface="Arial" pitchFamily="34" charset="-120"/>
               </a:rPr>
-              <a:t>Operational reporting + full audit log.</a:t>
+              <a:t>Reporting, audit log, and a multilingual UI (12 languages + English, RTL).</a:t>
             </a:r>
             <a:endParaRPr lang="en-US" sz="1300" dirty="0"/>
           </a:p>
@@ -5280,7 +5280,7 @@
                 <a:ea typeface="Arial" pitchFamily="34" charset="-122"/>
                 <a:cs typeface="Arial" pitchFamily="34" charset="-120"/>
               </a:rPr>
-              <a:t>In-house Video Conferencing</a:t>
+              <a:t>In-house Video + AI</a:t>
             </a:r>
             <a:endParaRPr lang="en-US" sz="1500" dirty="0"/>
           </a:p>
@@ -5344,7 +5344,7 @@
                 <a:ea typeface="Arial" pitchFamily="34" charset="-122"/>
                 <a:cs typeface="Arial" pitchFamily="34" charset="-120"/>
               </a:rPr>
-              <a:t>Multi-party video + audio (full mesh).</a:t>
+              <a:t>Multi-party video, mute, camera, screen share, chat.</a:t>
             </a:r>
             <a:endParaRPr lang="en-US" sz="1300" dirty="0"/>
           </a:p>
@@ -5365,7 +5365,7 @@
                 <a:ea typeface="Arial" pitchFamily="34" charset="-122"/>
                 <a:cs typeface="Arial" pitchFamily="34" charset="-120"/>
               </a:rPr>
-              <a:t>Mute, camera toggle, screen share, in-hearing chat.</a:t>
+              <a:t>Host (judge) controls: mute or remove a participant.</a:t>
             </a:r>
             <a:endParaRPr lang="en-US" sz="1300" dirty="0"/>
           </a:p>
@@ -5386,7 +5386,7 @@
                 <a:ea typeface="Arial" pitchFamily="34" charset="-122"/>
                 <a:cs typeface="Arial" pitchFamily="34" charset="-120"/>
               </a:rPr>
-              <a:t>Host (judge) controls: mute or remove a participant.</a:t>
+              <a:t>Live captions + interpreter translation; AI hearing summaries.</a:t>
             </a:r>
             <a:endParaRPr lang="en-US" sz="1300" dirty="0"/>
           </a:p>
@@ -5407,7 +5407,7 @@
                 <a:ea typeface="Arial" pitchFamily="34" charset="-122"/>
                 <a:cs typeface="Arial" pitchFamily="34" charset="-120"/>
               </a:rPr>
-              <a:t>Recording indicator / presence capture.</a:t>
+              <a:t>Recording saved server-side (playback in supervisor view).</a:t>
             </a:r>
             <a:endParaRPr lang="en-US" sz="1300" dirty="0"/>
           </a:p>
@@ -9007,7 +9007,7 @@
                 <a:ea typeface="Arial" pitchFamily="34" charset="-122"/>
                 <a:cs typeface="Arial" pitchFamily="34" charset="-120"/>
               </a:rPr>
-              <a:t>all required parties</a:t>
+              <a:t>participant(s)</a:t>
             </a:r>
             <a:endParaRPr lang="en-US" sz="900" dirty="0"/>
           </a:p>
@@ -10506,7 +10506,7 @@
                 <a:ea typeface="Arial" pitchFamily="34" charset="-122"/>
                 <a:cs typeface="Arial" pitchFamily="34" charset="-120"/>
               </a:rPr>
-              <a:t>Live roster</a:t>
+              <a:t>Live captions</a:t>
             </a:r>
             <a:endParaRPr lang="en-US" sz="1000" dirty="0"/>
           </a:p>
@@ -10557,7 +10557,7 @@
                 <a:ea typeface="Arial" pitchFamily="34" charset="-122"/>
                 <a:cs typeface="Arial" pitchFamily="34" charset="-120"/>
               </a:rPr>
-              <a:t>Host: mute participant</a:t>
+              <a:t>Interpreter translation</a:t>
             </a:r>
             <a:endParaRPr lang="en-US" sz="1000" dirty="0"/>
           </a:p>
@@ -10608,7 +10608,7 @@
                 <a:ea typeface="Arial" pitchFamily="34" charset="-122"/>
                 <a:cs typeface="Arial" pitchFamily="34" charset="-120"/>
               </a:rPr>
-              <a:t>Host: remove participant</a:t>
+              <a:t>Host: mute / remove</a:t>
             </a:r>
             <a:endParaRPr lang="en-US" sz="1000" dirty="0"/>
           </a:p>
@@ -10659,7 +10659,7 @@
                 <a:ea typeface="Arial" pitchFamily="34" charset="-122"/>
                 <a:cs typeface="Arial" pitchFamily="34" charset="-120"/>
               </a:rPr>
-              <a:t>Recording indicator</a:t>
+              <a:t>Recording (saved)</a:t>
             </a:r>
             <a:endParaRPr lang="en-US" sz="1000" dirty="0"/>
           </a:p>
@@ -10710,7 +10710,7 @@
                 <a:ea typeface="Arial" pitchFamily="34" charset="-122"/>
                 <a:cs typeface="Arial" pitchFamily="34" charset="-120"/>
               </a:rPr>
-              <a:t>Graceful media fallback</a:t>
+              <a:t>AI hearing summary</a:t>
             </a:r>
             <a:endParaRPr lang="en-US" sz="1000" dirty="0"/>
           </a:p>
@@ -12041,7 +12041,7 @@
                 <a:ea typeface="Arial" pitchFamily="34" charset="-122"/>
                 <a:cs typeface="Arial" pitchFamily="34" charset="-120"/>
               </a:rPr>
-              <a:t>Real components: nys-unavheader, nys-button, nys-icon, nys-badge, nys-skipnav.</a:t>
+              <a:t>Real components: nys-globalheader, nys-button, nys-icon, nys-badge.</a:t>
             </a:r>
             <a:endParaRPr lang="en-US" sz="1400" dirty="0"/>
           </a:p>
@@ -12062,7 +12062,7 @@
                 <a:ea typeface="Arial" pitchFamily="34" charset="-122"/>
                 <a:cs typeface="Arial" pitchFamily="34" charset="-120"/>
               </a:rPr>
-              <a:t>508 / WCAG: skip nav, visible focus, contrast, semantic landmarks.</a:t>
+              <a:t>Multilingual UI — NYS 12-language set + English, with RTL (Arabic / Urdu / Yiddish).</a:t>
             </a:r>
             <a:endParaRPr lang="en-US" sz="1400" dirty="0"/>
           </a:p>
@@ -12083,7 +12083,7 @@
                 <a:ea typeface="Arial" pitchFamily="34" charset="-122"/>
                 <a:cs typeface="Arial" pitchFamily="34" charset="-120"/>
               </a:rPr>
-              <a:t>Responsive — multi-device usage (desktop, tablet, phone).</a:t>
+              <a:t>508 / WCAG: visible focus, contrast, semantic landmarks, responsive multi-device.</a:t>
             </a:r>
             <a:endParaRPr lang="en-US" sz="1400" dirty="0"/>
           </a:p>
@@ -12713,7 +12713,7 @@
               <a:buNone/>
             </a:pPr>
             <a:r>
-              <a:rPr lang="en-US" sz="1300" dirty="0">
+              <a:rPr lang="en-US" sz="1200" dirty="0">
                 <a:solidFill>
                   <a:srgbClr val="154973"/>
                 </a:solidFill>
@@ -12721,9 +12721,9 @@
                 <a:ea typeface="Arial" pitchFamily="34" charset="-122"/>
                 <a:cs typeface="Arial" pitchFamily="34" charset="-120"/>
               </a:rPr>
-              <a:t>9 roles · 6-state status machine · live multi-tab sync · audit log · reporting — all delivered in a single, dependency-light app.</a:t>
-            </a:r>
-            <a:endParaRPr lang="en-US" sz="1300" dirty="0"/>
+              <a:t>9 roles · 6-state status machine · live multi-tab sync · in-house video + recording · AI captions/translation/summaries · 13-language UI · audit + reporting — one dependency-light app.</a:t>
+            </a:r>
+            <a:endParaRPr lang="en-US" sz="1200" dirty="0"/>
           </a:p>
         </p:txBody>
       </p:sp>

</xml_diff>

<commit_message>
Deck: move completed AI features out of Phase 3 roadmap into built features
- Slide 3: add predictive wait-times to the built feature list (captions,
  translation, summaries already present on slides 3/8).
- Slide 11: Phase 3 now 'AI Hardening' with only the remaining production work
  (STT/MT/LLM hosting, accuracy tuning, legal-record handling, professional
  translations) — the four built AI features removed since they are complete.

Co-Authored-By: Claude Opus 4.8 <noreply@anthropic.com>
</commit_message>
<xml_diff>
--- a/VWR-Pitch-Deck.pptx
+++ b/VWR-Pitch-Deck.pptx
@@ -3634,7 +3634,7 @@
                 <a:ea typeface="Arial" pitchFamily="34" charset="-122"/>
                 <a:cs typeface="Arial" pitchFamily="34" charset="-120"/>
               </a:rPr>
-              <a:t>Phase 3 — AI-Augment ✓ built</a:t>
+              <a:t>Phase 3 — AI Hardening</a:t>
             </a:r>
             <a:endParaRPr lang="en-US" sz="1150" dirty="0"/>
           </a:p>
@@ -3677,7 +3677,7 @@
                 <a:ea typeface="Arial" pitchFamily="34" charset="-122"/>
                 <a:cs typeface="Arial" pitchFamily="34" charset="-120"/>
               </a:rPr>
-              <a:t>Live captions / transcription ✓</a:t>
+              <a:t>Production STT / MT / LLM hosting</a:t>
             </a:r>
             <a:endParaRPr lang="en-US" sz="1050" dirty="0"/>
           </a:p>
@@ -3698,7 +3698,7 @@
                 <a:ea typeface="Arial" pitchFamily="34" charset="-122"/>
                 <a:cs typeface="Arial" pitchFamily="34" charset="-120"/>
               </a:rPr>
-              <a:t>Translation assist for interpreters ✓</a:t>
+              <a:t>Accuracy tuning &amp; evaluation</a:t>
             </a:r>
             <a:endParaRPr lang="en-US" sz="1050" dirty="0"/>
           </a:p>
@@ -3719,7 +3719,7 @@
                 <a:ea typeface="Arial" pitchFamily="34" charset="-122"/>
                 <a:cs typeface="Arial" pitchFamily="34" charset="-120"/>
               </a:rPr>
-              <a:t>Automated hearing summaries ✓</a:t>
+              <a:t>Legal-record handling for AI output</a:t>
             </a:r>
             <a:endParaRPr lang="en-US" sz="1050" dirty="0"/>
           </a:p>
@@ -3740,28 +3740,7 @@
                 <a:ea typeface="Arial" pitchFamily="34" charset="-122"/>
                 <a:cs typeface="Arial" pitchFamily="34" charset="-120"/>
               </a:rPr>
-              <a:t>Predictive wait-times ✓</a:t>
-            </a:r>
-            <a:endParaRPr lang="en-US" sz="1050" dirty="0"/>
-          </a:p>
-          <a:p>
-            <a:pPr marL="342900" indent="-342900">
-              <a:spcAft>
-                <a:spcPts val="800"/>
-              </a:spcAft>
-              <a:buSzPct val="100000"/>
-              <a:buChar char="•"/>
-            </a:pPr>
-            <a:r>
-              <a:rPr lang="en-US" sz="1050" dirty="0">
-                <a:solidFill>
-                  <a:srgbClr val="1B1B1B"/>
-                </a:solidFill>
-                <a:latin typeface="Arial" pitchFamily="34" charset="0"/>
-                <a:ea typeface="Arial" pitchFamily="34" charset="-122"/>
-                <a:cs typeface="Arial" pitchFamily="34" charset="-120"/>
-              </a:rPr>
-              <a:t>Next: accuracy + legal-record handling</a:t>
+              <a:t>Professional language-access translations</a:t>
             </a:r>
             <a:endParaRPr lang="en-US" sz="1050" dirty="0"/>
           </a:p>
@@ -5208,7 +5187,7 @@
                 <a:ea typeface="Arial" pitchFamily="34" charset="-122"/>
                 <a:cs typeface="Arial" pitchFamily="34" charset="-120"/>
               </a:rPr>
-              <a:t>Supervisor oversight: search, sort, filter, live statuses, recordings.</a:t>
+              <a:t>Supervisor oversight: search, sort, filter, live statuses, recordings, predictive wait-times.</a:t>
             </a:r>
             <a:endParaRPr lang="en-US" sz="1300" dirty="0"/>
           </a:p>

</xml_diff>